<commit_message>
Fixed MUST to MUST/SHOULD
</commit_message>
<xml_diff>
--- a/IETF-126-TSVWG-SCTP-DTLS-Chunk.pptx
+++ b/IETF-126-TSVWG-SCTP-DTLS-Chunk.pptx
@@ -65,12 +65,10 @@
 </p:presentation>
 </file>
 
-<file path=ppt/revisionInfo.xml><?xml version="1.0" encoding="utf-8"?>
-<p1510:revInfo xmlns:a="http://schemas.openxmlformats.org/drawingml/2006/main" xmlns:r="http://schemas.openxmlformats.org/officeDocument/2006/relationships" xmlns:p1510="http://schemas.microsoft.com/office/powerpoint/2015/10/main">
-  <p1510:revLst>
-    <p1510:client id="{9C4ECF09-2665-384A-8528-82C99FA27729}" v="35" dt="2026-07-16T13:06:01.784"/>
-  </p1510:revLst>
-</p1510:revInfo>
+<file path=ppt/authors.xml><?xml version="1.0" encoding="utf-8"?>
+<p188:authorLst xmlns:a="http://schemas.openxmlformats.org/drawingml/2006/main" xmlns:r="http://schemas.openxmlformats.org/officeDocument/2006/relationships" xmlns:p188="http://schemas.microsoft.com/office/powerpoint/2018/8/main">
+  <p188:author id="{AD1D1FE1-8989-AC62-B09F-3A4283D2C96E}" name="John Mattsson" initials="JP" userId="S::john.mattsson@ericsson.com::af1d955f-31b2-4b66-a94f-49d4d7f7d266" providerId="AD"/>
+</p188:authorLst>
 </file>
 
 <file path=ppt/changesInfos/changesInfo1.xml><?xml version="1.0" encoding="utf-8"?>
@@ -78,7 +76,7 @@
   <pc:docChgLst>
     <pc:chgData name="Magnus Westerlund" userId="d1f911fd-f2d9-4af0-9810-372c2434ea9e" providerId="ADAL" clId="{7C0B1DB3-C1BB-5C7B-ADA6-81A78F8132A4}"/>
     <pc:docChg chg="custSel modSld">
-      <pc:chgData name="Magnus Westerlund" userId="d1f911fd-f2d9-4af0-9810-372c2434ea9e" providerId="ADAL" clId="{7C0B1DB3-C1BB-5C7B-ADA6-81A78F8132A4}" dt="2026-07-17T14:11:05.116" v="169" actId="20577"/>
+      <pc:chgData name="Magnus Westerlund" userId="d1f911fd-f2d9-4af0-9810-372c2434ea9e" providerId="ADAL" clId="{7C0B1DB3-C1BB-5C7B-ADA6-81A78F8132A4}" dt="2026-07-18T12:35:02.143" v="176" actId="20577"/>
       <pc:docMkLst>
         <pc:docMk/>
       </pc:docMkLst>
@@ -128,6 +126,21 @@
         </pc:spChg>
       </pc:sldChg>
       <pc:sldChg chg="modSp mod">
+        <pc:chgData name="Magnus Westerlund" userId="d1f911fd-f2d9-4af0-9810-372c2434ea9e" providerId="ADAL" clId="{7C0B1DB3-C1BB-5C7B-ADA6-81A78F8132A4}" dt="2026-07-18T12:35:02.143" v="176" actId="20577"/>
+        <pc:sldMkLst>
+          <pc:docMk/>
+          <pc:sldMk cId="2124198194" sldId="274"/>
+        </pc:sldMkLst>
+        <pc:spChg chg="mod">
+          <ac:chgData name="Magnus Westerlund" userId="d1f911fd-f2d9-4af0-9810-372c2434ea9e" providerId="ADAL" clId="{7C0B1DB3-C1BB-5C7B-ADA6-81A78F8132A4}" dt="2026-07-18T12:35:02.143" v="176" actId="20577"/>
+          <ac:spMkLst>
+            <pc:docMk/>
+            <pc:sldMk cId="2124198194" sldId="274"/>
+            <ac:spMk id="4" creationId="{314A80B3-1CF1-518A-C35B-B27359B70B41}"/>
+          </ac:spMkLst>
+        </pc:spChg>
+      </pc:sldChg>
+      <pc:sldChg chg="modSp mod">
         <pc:chgData name="Magnus Westerlund" userId="d1f911fd-f2d9-4af0-9810-372c2434ea9e" providerId="ADAL" clId="{7C0B1DB3-C1BB-5C7B-ADA6-81A78F8132A4}" dt="2026-07-17T14:11:05.116" v="169" actId="20577"/>
         <pc:sldMkLst>
           <pc:docMk/>
@@ -154,6 +167,61 @@
             <pc:docMk/>
             <pc:sldMk cId="1304617088" sldId="276"/>
             <ac:spMk id="3" creationId="{A34535F1-01E7-D3B7-FF34-E094F215875B}"/>
+          </ac:spMkLst>
+        </pc:spChg>
+      </pc:sldChg>
+    </pc:docChg>
+  </pc:docChgLst>
+  <pc:docChgLst>
+    <pc:chgData name="John Mattsson" userId="af1d955f-31b2-4b66-a94f-49d4d7f7d266" providerId="ADAL" clId="{CEB9C44D-A79E-5021-A295-4255D07D6C4D}"/>
+    <pc:docChg chg="modSld">
+      <pc:chgData name="John Mattsson" userId="af1d955f-31b2-4b66-a94f-49d4d7f7d266" providerId="ADAL" clId="{CEB9C44D-A79E-5021-A295-4255D07D6C4D}" dt="2026-07-18T12:22:09.255" v="4" actId="2"/>
+      <pc:docMkLst>
+        <pc:docMk/>
+      </pc:docMkLst>
+      <pc:sldChg chg="modSp mod">
+        <pc:chgData name="John Mattsson" userId="af1d955f-31b2-4b66-a94f-49d4d7f7d266" providerId="ADAL" clId="{CEB9C44D-A79E-5021-A295-4255D07D6C4D}" dt="2026-07-18T12:22:09.255" v="4" actId="2"/>
+        <pc:sldMkLst>
+          <pc:docMk/>
+          <pc:sldMk cId="2604203220" sldId="272"/>
+        </pc:sldMkLst>
+        <pc:spChg chg="mod">
+          <ac:chgData name="John Mattsson" userId="af1d955f-31b2-4b66-a94f-49d4d7f7d266" providerId="ADAL" clId="{CEB9C44D-A79E-5021-A295-4255D07D6C4D}" dt="2026-07-18T12:22:09.255" v="4" actId="2"/>
+          <ac:spMkLst>
+            <pc:docMk/>
+            <pc:sldMk cId="2604203220" sldId="272"/>
+            <ac:spMk id="5" creationId="{80CFE1E9-2446-4327-A152-D121E1DA7E83}"/>
+          </ac:spMkLst>
+        </pc:spChg>
+      </pc:sldChg>
+      <pc:sldChg chg="modSp mod">
+        <pc:chgData name="John Mattsson" userId="af1d955f-31b2-4b66-a94f-49d4d7f7d266" providerId="ADAL" clId="{CEB9C44D-A79E-5021-A295-4255D07D6C4D}" dt="2026-07-18T12:22:04.383" v="2" actId="2"/>
+        <pc:sldMkLst>
+          <pc:docMk/>
+          <pc:sldMk cId="2764015099" sldId="275"/>
+        </pc:sldMkLst>
+        <pc:spChg chg="mod">
+          <ac:chgData name="John Mattsson" userId="af1d955f-31b2-4b66-a94f-49d4d7f7d266" providerId="ADAL" clId="{CEB9C44D-A79E-5021-A295-4255D07D6C4D}" dt="2026-07-18T12:22:02.332" v="0" actId="2"/>
+          <ac:spMkLst>
+            <pc:docMk/>
+            <pc:sldMk cId="2764015099" sldId="275"/>
+            <ac:spMk id="5" creationId="{960C9FF5-1894-156C-43F6-643A7F7A1C7D}"/>
+          </ac:spMkLst>
+        </pc:spChg>
+        <pc:spChg chg="mod">
+          <ac:chgData name="John Mattsson" userId="af1d955f-31b2-4b66-a94f-49d4d7f7d266" providerId="ADAL" clId="{CEB9C44D-A79E-5021-A295-4255D07D6C4D}" dt="2026-07-18T12:22:03.706" v="1" actId="2"/>
+          <ac:spMkLst>
+            <pc:docMk/>
+            <pc:sldMk cId="2764015099" sldId="275"/>
+            <ac:spMk id="22" creationId="{FAC3E9BB-C227-E96B-3FEB-9ABF5D4273B9}"/>
+          </ac:spMkLst>
+        </pc:spChg>
+        <pc:spChg chg="mod">
+          <ac:chgData name="John Mattsson" userId="af1d955f-31b2-4b66-a94f-49d4d7f7d266" providerId="ADAL" clId="{CEB9C44D-A79E-5021-A295-4255D07D6C4D}" dt="2026-07-18T12:22:04.383" v="2" actId="2"/>
+          <ac:spMkLst>
+            <pc:docMk/>
+            <pc:sldMk cId="2764015099" sldId="275"/>
+            <ac:spMk id="24" creationId="{094B2021-F91A-99ED-75B0-508368A658F3}"/>
           </ac:spMkLst>
         </pc:spChg>
       </pc:sldChg>
@@ -1704,7 +1772,7 @@
               <a:buFont typeface="Ericsson Hilda" panose="00000500000000000000" pitchFamily="2" charset="0"/>
               <a:buChar char="●"/>
             </a:pPr>
-            <a:endParaRPr lang="en-US" dirty="0" err="1">
+            <a:endParaRPr lang="en-US" dirty="0">
               <a:solidFill>
                 <a:schemeClr val="bg1"/>
               </a:solidFill>
@@ -2356,7 +2424,7 @@
               <a:buFont typeface="Ericsson Hilda" panose="00000500000000000000" pitchFamily="2" charset="0"/>
               <a:buChar char="●"/>
             </a:pPr>
-            <a:endParaRPr lang="en-US" dirty="0" err="1">
+            <a:endParaRPr lang="en-US" dirty="0">
               <a:solidFill>
                 <a:schemeClr val="bg1"/>
               </a:solidFill>
@@ -3164,7 +3232,7 @@
               <a:buFont typeface="Ericsson Hilda" panose="00000500000000000000" pitchFamily="2" charset="0"/>
               <a:buChar char="●"/>
             </a:pPr>
-            <a:endParaRPr lang="en-US" dirty="0" err="1">
+            <a:endParaRPr lang="en-US" dirty="0">
               <a:solidFill>
                 <a:schemeClr val="bg1"/>
               </a:solidFill>
@@ -4107,7 +4175,7 @@
               <a:buFont typeface="Ericsson Hilda" panose="00000500000000000000" pitchFamily="2" charset="0"/>
               <a:buChar char="●"/>
             </a:pPr>
-            <a:endParaRPr lang="en-US" dirty="0" err="1">
+            <a:endParaRPr lang="en-US" dirty="0">
               <a:solidFill>
                 <a:schemeClr val="bg1"/>
               </a:solidFill>
@@ -5182,7 +5250,7 @@
               <a:buFont typeface="Ericsson Hilda" panose="00000500000000000000" pitchFamily="2" charset="0"/>
               <a:buChar char="●"/>
             </a:pPr>
-            <a:endParaRPr lang="en-US" dirty="0" err="1">
+            <a:endParaRPr lang="en-US" dirty="0">
               <a:solidFill>
                 <a:schemeClr val="bg1"/>
               </a:solidFill>
@@ -6523,7 +6591,7 @@
               <a:buFont typeface="Ericsson Hilda" panose="00000500000000000000" pitchFamily="2" charset="0"/>
               <a:buChar char="●"/>
             </a:pPr>
-            <a:endParaRPr lang="en-US" dirty="0" err="1">
+            <a:endParaRPr lang="en-US" dirty="0">
               <a:solidFill>
                 <a:schemeClr val="bg1"/>
               </a:solidFill>
@@ -6933,7 +7001,7 @@
               <a:buFont typeface="Ericsson Hilda" panose="00000500000000000000" pitchFamily="2" charset="0"/>
               <a:buChar char="●"/>
             </a:pPr>
-            <a:endParaRPr lang="en-US" dirty="0" err="1">
+            <a:endParaRPr lang="en-US" dirty="0">
               <a:solidFill>
                 <a:schemeClr val="bg1"/>
               </a:solidFill>
@@ -7875,7 +7943,7 @@
               <a:buFont typeface="Ericsson Hilda" panose="00000500000000000000" pitchFamily="2" charset="0"/>
               <a:buChar char="●"/>
             </a:pPr>
-            <a:endParaRPr lang="en-US" dirty="0" err="1">
+            <a:endParaRPr lang="en-US" dirty="0">
               <a:solidFill>
                 <a:schemeClr val="bg1"/>
               </a:solidFill>
@@ -9044,7 +9112,7 @@
               <a:buFont typeface="Ericsson Hilda" panose="00000500000000000000" pitchFamily="2" charset="0"/>
               <a:buChar char="●"/>
             </a:pPr>
-            <a:endParaRPr lang="en-US" dirty="0" err="1">
+            <a:endParaRPr lang="en-US" dirty="0">
               <a:solidFill>
                 <a:schemeClr val="bg1"/>
               </a:solidFill>
@@ -9338,7 +9406,7 @@
               <a:buFont typeface="Ericsson Hilda" panose="00000500000000000000" pitchFamily="2" charset="0"/>
               <a:buChar char="●"/>
             </a:pPr>
-            <a:endParaRPr lang="en-US" dirty="0" err="1">
+            <a:endParaRPr lang="en-US" dirty="0">
               <a:solidFill>
                 <a:schemeClr val="bg1"/>
               </a:solidFill>
@@ -9786,7 +9854,7 @@
               <a:buFont typeface="Ericsson Hilda" panose="00000500000000000000" pitchFamily="2" charset="0"/>
               <a:buChar char="●"/>
             </a:pPr>
-            <a:endParaRPr lang="en-US" dirty="0" err="1">
+            <a:endParaRPr lang="en-US" dirty="0">
               <a:solidFill>
                 <a:schemeClr val="bg1"/>
               </a:solidFill>
@@ -11712,7 +11780,15 @@
           <a:p>
             <a:r>
               <a:rPr lang="en-US" dirty="0"/>
-              <a:t>Clarified Mandatory to Implement Ciphers that unless something else specifies it one MUST implement:</a:t>
+              <a:t>Clarified Mandatory to Implement Ciphers that unless something else specifies it </a:t>
+            </a:r>
+            <a:r>
+              <a:rPr lang="en-US"/>
+              <a:t>one MUST/SHOULD </a:t>
+            </a:r>
+            <a:r>
+              <a:rPr lang="en-US" dirty="0"/>
+              <a:t>implement:</a:t>
             </a:r>
           </a:p>
           <a:p>
@@ -11793,7 +11869,7 @@
               <a:buFont typeface="Arial" panose="020B0604020202020204" pitchFamily="34" charset="0"/>
               <a:buChar char="•"/>
             </a:pPr>
-            <a:endParaRPr kumimoji="0" lang="en-US" sz="2000" b="0" i="0" u="none" strike="noStrike" kern="1000" cap="none" spc="-30" normalizeH="0" baseline="0" noProof="0" dirty="0" err="1">
+            <a:endParaRPr kumimoji="0" lang="en-US" sz="2000" b="0" i="0" u="none" strike="noStrike" kern="1000" cap="none" spc="-30" normalizeH="0" baseline="0" noProof="0" dirty="0">
               <a:ln>
                 <a:noFill/>
               </a:ln>
@@ -12080,15 +12156,7 @@
           <a:p>
             <a:r>
               <a:rPr lang="en-US" dirty="0"/>
-              <a:t>Interoperability achieved between </a:t>
-            </a:r>
-            <a:r>
-              <a:rPr lang="en-US" dirty="0" err="1"/>
-              <a:t>Redhat’s</a:t>
-            </a:r>
-            <a:r>
-              <a:rPr lang="en-US" dirty="0"/>
-              <a:t> Linux SCTP Implementation and Ericsson’s user space stack using the key-management method of </a:t>
+              <a:t>Interoperability achieved between Redhat’s Linux SCTP Implementation and Ericsson’s user space stack using the key-management method of </a:t>
             </a:r>
             <a:r>
               <a:rPr lang="en-SE" dirty="0">
@@ -12819,10 +12887,9 @@
               </a:spcBef>
             </a:pPr>
             <a:r>
-              <a:rPr lang="en-US" dirty="0" err="1"/>
+              <a:rPr lang="en-US" dirty="0"/>
               <a:t>WolfSSL</a:t>
             </a:r>
-            <a:endParaRPr lang="en-US" dirty="0"/>
           </a:p>
         </p:txBody>
       </p:sp>
@@ -12879,10 +12946,9 @@
               </a:spcBef>
             </a:pPr>
             <a:r>
-              <a:rPr lang="en-US" dirty="0" err="1"/>
+              <a:rPr lang="en-US" dirty="0"/>
               <a:t>WolfSSL</a:t>
             </a:r>
-            <a:endParaRPr lang="en-US" dirty="0"/>
           </a:p>
         </p:txBody>
       </p:sp>
@@ -12968,7 +13034,7 @@
               <a:buSzTx/>
               <a:tabLst/>
             </a:pPr>
-            <a:endParaRPr kumimoji="0" lang="en-US" sz="2000" b="0" i="0" u="none" strike="noStrike" kern="1000" cap="none" spc="-30" normalizeH="0" baseline="0" noProof="0" dirty="0" err="1">
+            <a:endParaRPr kumimoji="0" lang="en-US" sz="2000" b="0" i="0" u="none" strike="noStrike" kern="1000" cap="none" spc="-30" normalizeH="0" baseline="0" noProof="0" dirty="0">
               <a:ln>
                 <a:noFill/>
               </a:ln>
@@ -13074,45 +13140,13 @@
           <a:p>
             <a:r>
               <a:rPr lang="en-US" dirty="0"/>
-              <a:t>Pre-shared Key has been used for validating the DTLS 1.3 implementation in Linux Kernel SCTP versus the </a:t>
-            </a:r>
-            <a:r>
-              <a:rPr lang="en-US" dirty="0" err="1"/>
-              <a:t>WolfSSL</a:t>
-            </a:r>
-            <a:r>
-              <a:rPr lang="en-US" dirty="0"/>
-              <a:t> implementation</a:t>
-            </a:r>
-          </a:p>
-          <a:p>
-            <a:r>
-              <a:rPr lang="en-US" dirty="0"/>
-              <a:t>Implementation of the TLS 1.3 based Key Management of draft-</a:t>
-            </a:r>
-            <a:r>
-              <a:rPr lang="en-US" dirty="0" err="1"/>
-              <a:t>porfiri</a:t>
-            </a:r>
-            <a:r>
-              <a:rPr lang="en-US" dirty="0"/>
-              <a:t>-</a:t>
-            </a:r>
-            <a:r>
-              <a:rPr lang="en-US" dirty="0" err="1"/>
-              <a:t>sctp</a:t>
-            </a:r>
-            <a:r>
-              <a:rPr lang="en-US" dirty="0"/>
-              <a:t>-</a:t>
-            </a:r>
-            <a:r>
-              <a:rPr lang="en-US" dirty="0" err="1"/>
-              <a:t>dtls</a:t>
-            </a:r>
-            <a:r>
-              <a:rPr lang="en-US" dirty="0"/>
-              <a:t>-handshake to validate its specification</a:t>
+              <a:t>Pre-shared Key has been used for validating the DTLS 1.3 implementation in Linux Kernel SCTP versus the WolfSSL implementation</a:t>
+            </a:r>
+          </a:p>
+          <a:p>
+            <a:r>
+              <a:rPr lang="en-US" dirty="0"/>
+              <a:t>Implementation of the TLS 1.3 based Key Management of draft-porfiri-sctp-dtls-handshake to validate its specification</a:t>
             </a:r>
           </a:p>
           <a:p>

</xml_diff>

<commit_message>
Possibly some edits to reflect submitted version.
</commit_message>
<xml_diff>
--- a/IETF-126-TSVWG-SCTP-DTLS-Chunk.pptx
+++ b/IETF-126-TSVWG-SCTP-DTLS-Chunk.pptx
@@ -25,31 +25,28 @@
   <p:notesSz cx="6858000" cy="9144000"/>
   <p:embeddedFontLst>
     <p:embeddedFont>
-      <p:font typeface="Ericsson Hilda" panose="020B0604020202020204" charset="0"/>
+      <p:font typeface="Ericsson Hilda" pitchFamily="2" charset="0"/>
       <p:regular r:id="rId28"/>
       <p:bold r:id="rId29"/>
-      <p:italic r:id="rId30"/>
-      <p:boldItalic r:id="rId31"/>
     </p:embeddedFont>
     <p:embeddedFont>
-      <p:font typeface="Ericsson Hilda ExtraBold" panose="020B0604020202020204" charset="0"/>
-      <p:bold r:id="rId32"/>
+      <p:font typeface="Ericsson Hilda ExtraBold" pitchFamily="2" charset="0"/>
+      <p:bold r:id="rId30"/>
     </p:embeddedFont>
     <p:embeddedFont>
-      <p:font typeface="Ericsson Hilda ExtraLight" panose="020B0604020202020204" charset="0"/>
-      <p:regular r:id="rId33"/>
+      <p:font typeface="Ericsson Hilda ExtraLight" pitchFamily="2" charset="0"/>
+      <p:regular r:id="rId31"/>
     </p:embeddedFont>
     <p:embeddedFont>
-      <p:font typeface="Ericsson Hilda Light" panose="020B0604020202020204" charset="0"/>
-      <p:regular r:id="rId34"/>
-      <p:italic r:id="rId35"/>
+      <p:font typeface="Ericsson Hilda Light" pitchFamily="2" charset="0"/>
+      <p:regular r:id="rId32"/>
     </p:embeddedFont>
     <p:embeddedFont>
-      <p:font typeface="Ericsson Technical Icons" panose="020B0604020202020204" charset="0"/>
-      <p:regular r:id="rId36"/>
-      <p:bold r:id="rId37"/>
-      <p:italic r:id="rId38"/>
-      <p:boldItalic r:id="rId39"/>
+      <p:font typeface="Ericsson Technical Icons" pitchFamily="2" charset="0"/>
+      <p:regular r:id="rId33"/>
+      <p:bold r:id="rId34"/>
+      <p:italic r:id="rId35"/>
+      <p:boldItalic r:id="rId36"/>
     </p:embeddedFont>
   </p:embeddedFontLst>
   <p:defaultTextStyle>
@@ -14905,54 +14902,67 @@
           <a:lstStyle/>
           <a:p>
             <a:r>
-              <a:rPr lang="en-US"/>
+              <a:rPr lang="en-US" dirty="0"/>
               <a:t>The Design Team considers DTLS Chunk specification to be stable when it comes to format and functionality</a:t>
             </a:r>
           </a:p>
           <a:p>
             <a:pPr lvl="1"/>
             <a:r>
-              <a:rPr lang="en-US"/>
+              <a:rPr lang="en-US" dirty="0"/>
               <a:t>Two independent implementations</a:t>
             </a:r>
           </a:p>
           <a:p>
             <a:pPr lvl="1"/>
             <a:r>
-              <a:rPr lang="en-US"/>
+              <a:rPr lang="en-US" dirty="0"/>
               <a:t>Interoperability tests has shown that specification works</a:t>
             </a:r>
           </a:p>
           <a:p>
             <a:r>
-              <a:rPr lang="en-US"/>
+              <a:rPr lang="en-US" dirty="0"/>
               <a:t>Specification text has improved significantly</a:t>
             </a:r>
+          </a:p>
+          <a:p>
+            <a:r>
+              <a:rPr lang="en-US" dirty="0"/>
+              <a:t>Have requested early allocation of </a:t>
+            </a:r>
+            <a:r>
+              <a:rPr lang="en-US"/>
+              <a:t>error causes</a:t>
+            </a:r>
+          </a:p>
+          <a:p>
+            <a:endParaRPr lang="en-US" dirty="0"/>
+          </a:p>
+          <a:p>
+            <a:r>
+              <a:rPr lang="en-US" dirty="0"/>
+              <a:t>The Design Team requests reviews of the DTLS Chunk</a:t>
+            </a:r>
+          </a:p>
+          <a:p>
+            <a:pPr lvl="1"/>
+            <a:r>
+              <a:rPr lang="en-US" dirty="0"/>
+              <a:t>Consider to send LS to 3GPP on progress and request reviews</a:t>
+            </a:r>
+          </a:p>
+          <a:p>
+            <a:pPr marL="0" indent="0">
+              <a:buNone/>
+            </a:pPr>
+            <a:endParaRPr lang="en-US" dirty="0"/>
           </a:p>
           <a:p>
             <a:pPr marL="265113" lvl="1" indent="0">
               <a:buNone/>
             </a:pPr>
-            <a:endParaRPr lang="en-US"/>
-          </a:p>
-          <a:p>
-            <a:r>
-              <a:rPr lang="en-US"/>
-              <a:t>The Design Team requests reviews of the DTLS Chunk</a:t>
-            </a:r>
-          </a:p>
-          <a:p>
-            <a:pPr lvl="1"/>
-            <a:r>
-              <a:rPr lang="en-US"/>
-              <a:t>Consider to send LS to 3GPP on progress and request reviews</a:t>
-            </a:r>
-          </a:p>
-          <a:p>
-            <a:pPr marL="265113" lvl="1" indent="0">
-              <a:buNone/>
-            </a:pPr>
-            <a:endParaRPr lang="en-US"/>
+            <a:endParaRPr lang="en-US" dirty="0"/>
           </a:p>
         </p:txBody>
       </p:sp>
@@ -16232,11 +16242,13 @@
 </file>
 
 <file path=customXml/item1.xml><?xml version="1.0" encoding="utf-8"?>
-<TemplafySlideTemplateConfiguration><![CDATA[{"documentContentValidatorConfiguration":{"enableDocumentContentValidator":false,"documentContentValidatorVersion":0},"elementsMetadata":[],"slideId":"638780731662370544","enableDocumentContentUpdater":true,"version":"1.9"}]]></TemplafySlideTemplateConfiguration>
+<p:properties xmlns:p="http://schemas.microsoft.com/office/2006/metadata/properties" xmlns:xsi="http://www.w3.org/2001/XMLSchema-instance" xmlns:pc="http://schemas.microsoft.com/office/infopath/2007/PartnerControls">
+  <documentManagement/>
+</p:properties>
 </file>
 
 <file path=customXml/item10.xml><?xml version="1.0" encoding="utf-8"?>
-<TemplafySlideFormConfiguration><![CDATA[{"formFields":[],"formDataEntries":[]}]]></TemplafySlideFormConfiguration>
+<TemplafyFormConfiguration><![CDATA[{"formFields":[{"required":true,"placeholder":"","lines":0,"helpTexts":{"prefix":"","postfix":""},"spacing":{},"type":"textBox","name":"DocumentTitle","label":"Document Title","fullyQualifiedName":"DocumentTitle"},{"dataSource":"Confidentiality","displayColumn":"confidentiality","hideIfNoUserInteractionRequired":false,"distinct":true,"required":true,"autoSelectFirstOption":false,"helpTexts":{"prefix":"","postfix":""},"spacing":{},"type":"dropDown","name":"ConfidentialityClass","label":"Confidentiality Class","fullyQualifiedName":"ConfidentialityClass"},{"dataSource":"External Confidentiality label","displayColumn":"externalConfidentiality","hideIfNoUserInteractionRequired":false,"distinct":true,"required":false,"autoSelectFirstOption":false,"helpTexts":{"prefix":"","postfix":"(If no external confidentiality class then please choose the blank value)"},"spacing":{},"type":"dropDown","name":"ExternalConfidentialityLabel","label":"External Confidentiality label","fullyQualifiedName":"ExternalConfidentialityLabel"},{"column":"documentType","required":false,"placeholder":"","autoSelectFirstOption":false,"helpTexts":{"prefix":"","postfix":""},"spacing":{},"dataSource":"PowerPoint Document Type","type":"comboBox","name":"DocTypePresentation","label":"Document Type","fullyQualifiedName":"DocTypePresentation"},{"required":false,"placeholder":"","lines":0,"helpTexts":{"prefix":"","postfix":"(Commonly assigned by EriDoc)"},"spacing":{},"type":"textBox","name":"DocumentNumber","label":"Document Number","fullyQualifiedName":"DocumentNumber"},{"dataSource":"Language code","displayColumn":"showName","defaultValue":"1","hideIfNoUserInteractionRequired":false,"distinct":true,"required":false,"autoSelectFirstOption":false,"helpTexts":{"prefix":"","postfix":"(The language code will be appended to the Document No.)"},"spacing":{},"type":"dropDown","name":"LanguageCode","label":"Language Code","fullyQualifiedName":"LanguageCode"},{"column":"revision","required":false,"placeholder":"","autoSelectFirstOption":false,"helpTexts":{"prefix":"","postfix":""},"spacing":{},"dataSource":"Revision","type":"comboBox","name":"Revision","label":"Revision","fullyQualifiedName":"Revision"},{"required":false,"helpTexts":{"prefix":"","postfix":""},"spacing":{},"type":"datePicker","name":"Date","label":"Date","fullyQualifiedName":"Date"},{"helpTexts":{"prefix":"","postfix":""},"spacing":{},"type":"heading","name":"FooterVisibilityOptions","label":"Footer Visibility Options","fullyQualifiedName":"FooterVisibilityOptions"},{"dataSource":"PPT FooterVisibility","displayColumn":"templateType","defaultValue":"1","hideIfNoUserInteractionRequired":false,"distinct":true,"required":true,"autoSelectFirstOption":false,"helpTexts":{"prefix":"","postfix":""},"spacing":{},"type":"dropDown","name":"TemplateType","label":"Is this a document or presentation?","fullyQualifiedName":"TemplateType"},{"dataSource":"PPT FooterVisibility","displayColumn":"docTitle_label","filter":{"column":"templateType","otherFieldName":"TemplateType","fullyQualifiedOtherFieldName":"TemplateType","otherFieldColumn":"TemplateType","formReference":"none","operator":"equals"},"hideIfNoUserInteractionRequired":false,"distinct":true,"required":false,"autoSelectFirstOption":true,"helpTexts":{"prefix":"","postfix":""},"spacing":{},"type":"dropDown","name":"DocTitle","label":"Show document title in footer?","fullyQualifiedName":"DocTitle"},{"dataSource":"PPT FooterVisibility","displayColumn":"totalPageNo_text","filter":{"column":"templateType","otherFieldName":"TemplateType","fullyQualifiedOtherFieldName":"TemplateType","otherFieldColumn":"TemplateType","formReference":"none","operator":"equals"},"hideIfNoUserInteractionRequired":false,"distinct":true,"required":false,"autoSelectFirstOption":true,"helpTexts":{"prefix":"","postfix":""},"spacing":{},"type":"dropDown","name":"TotalPageNo","label":"Page numbering","fullyQualifiedName":"TotalPageNo"},{"dataSource":"PPT FooterVisibility","displayColumn":"showDocNo_label","filter":{"column":"templateType","otherFieldName":"TemplateType","fullyQualifiedOtherFieldName":"TemplateType","otherFieldColumn":"TemplateType","formReference":"none","operator":"equals"},"hideIfNoUserInteractionRequired":false,"distinct":true,"required":false,"autoSelectFirstOption":true,"helpTexts":{"prefix":"","postfix":""},"spacing":{},"type":"dropDown","name":"DocNo","label":"Show document number in footer?","fullyQualifiedName":"DocNo"},{"required":false,"placeholder":"","lines":0,"defaultValue":"{{UserProfile.Prepared}}","helpTexts":{"prefix":"","postfix":""},"spacing":{},"type":"textBox","name":"Prepared","label":"Prepared By (Subject Responsible)","fullyQualifiedName":"Prepared"},{"required":false,"placeholder":"","lines":0,"helpTexts":{"prefix":"","postfix":""},"spacing":{},"type":"textBox","name":"ApprovedBy","label":"Approved By (Document Responsible)","fullyQualifiedName":"ApprovedBy"},{"required":false,"placeholder":"","lines":0,"helpTexts":{"prefix":"","postfix":""},"spacing":{},"type":"textBox","name":"Checked","label":"Checked","fullyQualifiedName":"Checked"},{"required":false,"placeholder":"","lines":0,"helpTexts":{"prefix":"","postfix":"(Overwritten with EriDoc values at check-in)"},"spacing":{},"type":"textBox","name":"Reference","label":"Reference","fullyQualifiedName":"Reference"},{"required":false,"placeholder":"","lines":0,"helpTexts":{"prefix":"","postfix":""},"spacing":{},"type":"textBox","name":"Keywords","label":"Keywords","fullyQualifiedName":"Keywords"}],"formDataEntries":[{"name":"DocumentTitle","value":"pYKnA1M1iVGe972lLW237tBCWABVWwTW03TtSWLVXT0="},{"name":"ConfidentialityClass","value":"cT/FOwTWaPknrhRlNMh4SQ=="},{"name":"LanguageCode","value":"5wlu7ZdPxHQj1W0w+yTNSg=="},{"name":"Date","value":"fbd86WXKelPa8nlkyyencA=="},{"name":"TemplateType","value":"5wlu7ZdPxHQj1W0w+yTNSg=="},{"name":"DocTitle","value":"5wlu7ZdPxHQj1W0w+yTNSg=="},{"name":"TotalPageNo","value":"cT/FOwTWaPknrhRlNMh4SQ=="},{"name":"DocNo","value":"5wlu7ZdPxHQj1W0w+yTNSg=="},{"name":"Prepared","value":"fdJUhNIjdwPGv3mvNZlQT4ASrQGRpusVL7uBTgJlxbo="}]}]]></TemplafyFormConfiguration>
 </file>
 
 <file path=customXml/item11.xml><?xml version="1.0" encoding="utf-8"?>
@@ -16244,19 +16256,19 @@
 </file>
 
 <file path=customXml/item12.xml><?xml version="1.0" encoding="utf-8"?>
+<TemplafySlideFormConfiguration><![CDATA[{"formFields":[],"formDataEntries":[]}]]></TemplafySlideFormConfiguration>
+</file>
+
+<file path=customXml/item13.xml><?xml version="1.0" encoding="utf-8"?>
+<TemplafySlideTemplateConfiguration><![CDATA[{"documentContentValidatorConfiguration":{"enableDocumentContentValidator":false,"documentContentValidatorVersion":0},"elementsMetadata":[],"slideId":"638780731662370545","enableDocumentContentUpdater":true,"version":"1.9"}]]></TemplafySlideTemplateConfiguration>
+</file>
+
+<file path=customXml/item14.xml><?xml version="1.0" encoding="utf-8"?>
 <TemplafySlideTemplateConfiguration><![CDATA[{"documentContentValidatorConfiguration":{"enableDocumentContentValidator":false,"documentContentValidatorVersion":0},"elementsMetadata":[],"slideId":"638780731662214300","enableDocumentContentUpdater":true,"version":"1.9"}]]></TemplafySlideTemplateConfiguration>
 </file>
 
-<file path=customXml/item13.xml><?xml version="1.0" encoding="utf-8"?>
+<file path=customXml/item15.xml><?xml version="1.0" encoding="utf-8"?>
 <TemplafySlideTemplateConfiguration><![CDATA[{"documentContentValidatorConfiguration":{"enableDocumentContentValidator":false,"documentContentValidatorVersion":0},"elementsMetadata":[],"slideId":"638780731662526815","enableDocumentContentUpdater":true,"version":"1.9"}]]></TemplafySlideTemplateConfiguration>
-</file>
-
-<file path=customXml/item14.xml><?xml version="1.0" encoding="utf-8"?>
-<TemplafySlideFormConfiguration><![CDATA[{"formFields":[],"formDataEntries":[]}]]></TemplafySlideFormConfiguration>
-</file>
-
-<file path=customXml/item15.xml><?xml version="1.0" encoding="utf-8"?>
-<TemplafySlideTemplateConfiguration><![CDATA[{"elementsMetadata":[],"documentContentValidatorConfiguration":{"enableDocumentContentValidator":false,"documentContentValidatorVersion":0},"slideId":"637027476704980324","enableDocumentContentUpdater":true,"version":"1.9"}]]></TemplafySlideTemplateConfiguration>
 </file>
 
 <file path=customXml/item2.xml><?xml version="1.0" encoding="utf-8"?>
@@ -16264,10 +16276,35 @@
 </file>
 
 <file path=customXml/item3.xml><?xml version="1.0" encoding="utf-8"?>
-<TemplafySlideTemplateConfiguration><![CDATA[{"documentContentValidatorConfiguration":{"enableDocumentContentValidator":false,"documentContentValidatorVersion":0},"elementsMetadata":[],"slideId":"638780731662370545","enableDocumentContentUpdater":true,"version":"1.9"}]]></TemplafySlideTemplateConfiguration>
+<TemplafySlideTemplateConfiguration><![CDATA[{"documentContentValidatorConfiguration":{"enableDocumentContentValidator":false,"documentContentValidatorVersion":0},"elementsMetadata":[],"slideId":"638780731662370544","enableDocumentContentUpdater":true,"version":"1.9"}]]></TemplafySlideTemplateConfiguration>
 </file>
 
 <file path=customXml/item4.xml><?xml version="1.0" encoding="utf-8"?>
+<?mso-contentType ?>
+<FormTemplates xmlns="http://schemas.microsoft.com/sharepoint/v3/contenttype/forms">
+  <Display>DocumentLibraryForm</Display>
+  <Edit>DocumentLibraryForm</Edit>
+  <New>DocumentLibraryForm</New>
+</FormTemplates>
+</file>
+
+<file path=customXml/item5.xml><?xml version="1.0" encoding="utf-8"?>
+<TemplafySlideFormConfiguration><![CDATA[{"formFields":[],"formDataEntries":[]}]]></TemplafySlideFormConfiguration>
+</file>
+
+<file path=customXml/item6.xml><?xml version="1.0" encoding="utf-8"?>
+<TemplafySlideFormConfiguration><![CDATA[{"formFields":[],"formDataEntries":[]}]]></TemplafySlideFormConfiguration>
+</file>
+
+<file path=customXml/item7.xml><?xml version="1.0" encoding="utf-8"?>
+<TemplafySlideTemplateConfiguration><![CDATA[{"elementsMetadata":[],"documentContentValidatorConfiguration":{"enableDocumentContentValidator":false,"documentContentValidatorVersion":0},"slideId":"637027476704980324","enableDocumentContentUpdater":true,"version":"1.9"}]]></TemplafySlideTemplateConfiguration>
+</file>
+
+<file path=customXml/item8.xml><?xml version="1.0" encoding="utf-8"?>
+<TemplafySlideFormConfiguration><![CDATA[{"formFields":[],"formDataEntries":[]}]]></TemplafySlideFormConfiguration>
+</file>
+
+<file path=customXml/item9.xml><?xml version="1.0" encoding="utf-8"?>
 <ct:contentTypeSchema xmlns:ct="http://schemas.microsoft.com/office/2006/metadata/contentType" xmlns:ma="http://schemas.microsoft.com/office/2006/metadata/properties/metaAttributes" ct:_="" ma:_="" ma:contentTypeName="Document" ma:contentTypeID="0x0101002C8661F604A9A64C9627B875CBEE0D49" ma:contentTypeVersion="15" ma:contentTypeDescription="Create a new document." ma:contentTypeScope="" ma:versionID="a479c757ef17ea2b01d6697cee2b70c6">
   <xsd:schema xmlns:xsd="http://www.w3.org/2001/XMLSchema" xmlns:xs="http://www.w3.org/2001/XMLSchema" xmlns:p="http://schemas.microsoft.com/office/2006/metadata/properties" xmlns:ns3="92e1255f-bb7b-4dc9-b051-584cc104eb44" xmlns:ns4="a6550eff-0fc9-443f-8e77-72cbcf778382" targetNamespace="http://schemas.microsoft.com/office/2006/metadata/properties" ma:root="true" ma:fieldsID="08df2d0f55032e4052d032aa8ec7ed1f" ns3:_="" ns4:_="">
     <xsd:import namespace="92e1255f-bb7b-4dc9-b051-584cc104eb44"/>
@@ -16504,71 +16541,55 @@
 </ct:contentTypeSchema>
 </file>
 
-<file path=customXml/item5.xml><?xml version="1.0" encoding="utf-8"?>
-<TemplafySlideFormConfiguration><![CDATA[{"formFields":[],"formDataEntries":[]}]]></TemplafySlideFormConfiguration>
-</file>
-
-<file path=customXml/item6.xml><?xml version="1.0" encoding="utf-8"?>
-<?mso-contentType ?>
-<FormTemplates xmlns="http://schemas.microsoft.com/sharepoint/v3/contenttype/forms">
-  <Display>DocumentLibraryForm</Display>
-  <Edit>DocumentLibraryForm</Edit>
-  <New>DocumentLibraryForm</New>
-</FormTemplates>
-</file>
-
-<file path=customXml/item7.xml><?xml version="1.0" encoding="utf-8"?>
-<p:properties xmlns:p="http://schemas.microsoft.com/office/2006/metadata/properties" xmlns:xsi="http://www.w3.org/2001/XMLSchema-instance" xmlns:pc="http://schemas.microsoft.com/office/infopath/2007/PartnerControls">
-  <documentManagement/>
-</p:properties>
-</file>
-
-<file path=customXml/item8.xml><?xml version="1.0" encoding="utf-8"?>
-<TemplafySlideFormConfiguration><![CDATA[{"formFields":[],"formDataEntries":[]}]]></TemplafySlideFormConfiguration>
-</file>
-
-<file path=customXml/item9.xml><?xml version="1.0" encoding="utf-8"?>
-<TemplafyFormConfiguration><![CDATA[{"formFields":[{"required":true,"placeholder":"","lines":0,"helpTexts":{"prefix":"","postfix":""},"spacing":{},"type":"textBox","name":"DocumentTitle","label":"Document Title","fullyQualifiedName":"DocumentTitle"},{"dataSource":"Confidentiality","displayColumn":"confidentiality","hideIfNoUserInteractionRequired":false,"distinct":true,"required":true,"autoSelectFirstOption":false,"helpTexts":{"prefix":"","postfix":""},"spacing":{},"type":"dropDown","name":"ConfidentialityClass","label":"Confidentiality Class","fullyQualifiedName":"ConfidentialityClass"},{"dataSource":"External Confidentiality label","displayColumn":"externalConfidentiality","hideIfNoUserInteractionRequired":false,"distinct":true,"required":false,"autoSelectFirstOption":false,"helpTexts":{"prefix":"","postfix":"(If no external confidentiality class then please choose the blank value)"},"spacing":{},"type":"dropDown","name":"ExternalConfidentialityLabel","label":"External Confidentiality label","fullyQualifiedName":"ExternalConfidentialityLabel"},{"column":"documentType","required":false,"placeholder":"","autoSelectFirstOption":false,"helpTexts":{"prefix":"","postfix":""},"spacing":{},"dataSource":"PowerPoint Document Type","type":"comboBox","name":"DocTypePresentation","label":"Document Type","fullyQualifiedName":"DocTypePresentation"},{"required":false,"placeholder":"","lines":0,"helpTexts":{"prefix":"","postfix":"(Commonly assigned by EriDoc)"},"spacing":{},"type":"textBox","name":"DocumentNumber","label":"Document Number","fullyQualifiedName":"DocumentNumber"},{"dataSource":"Language code","displayColumn":"showName","defaultValue":"1","hideIfNoUserInteractionRequired":false,"distinct":true,"required":false,"autoSelectFirstOption":false,"helpTexts":{"prefix":"","postfix":"(The language code will be appended to the Document No.)"},"spacing":{},"type":"dropDown","name":"LanguageCode","label":"Language Code","fullyQualifiedName":"LanguageCode"},{"column":"revision","required":false,"placeholder":"","autoSelectFirstOption":false,"helpTexts":{"prefix":"","postfix":""},"spacing":{},"dataSource":"Revision","type":"comboBox","name":"Revision","label":"Revision","fullyQualifiedName":"Revision"},{"required":false,"helpTexts":{"prefix":"","postfix":""},"spacing":{},"type":"datePicker","name":"Date","label":"Date","fullyQualifiedName":"Date"},{"helpTexts":{"prefix":"","postfix":""},"spacing":{},"type":"heading","name":"FooterVisibilityOptions","label":"Footer Visibility Options","fullyQualifiedName":"FooterVisibilityOptions"},{"dataSource":"PPT FooterVisibility","displayColumn":"templateType","defaultValue":"1","hideIfNoUserInteractionRequired":false,"distinct":true,"required":true,"autoSelectFirstOption":false,"helpTexts":{"prefix":"","postfix":""},"spacing":{},"type":"dropDown","name":"TemplateType","label":"Is this a document or presentation?","fullyQualifiedName":"TemplateType"},{"dataSource":"PPT FooterVisibility","displayColumn":"docTitle_label","filter":{"column":"templateType","otherFieldName":"TemplateType","fullyQualifiedOtherFieldName":"TemplateType","otherFieldColumn":"TemplateType","formReference":"none","operator":"equals"},"hideIfNoUserInteractionRequired":false,"distinct":true,"required":false,"autoSelectFirstOption":true,"helpTexts":{"prefix":"","postfix":""},"spacing":{},"type":"dropDown","name":"DocTitle","label":"Show document title in footer?","fullyQualifiedName":"DocTitle"},{"dataSource":"PPT FooterVisibility","displayColumn":"totalPageNo_text","filter":{"column":"templateType","otherFieldName":"TemplateType","fullyQualifiedOtherFieldName":"TemplateType","otherFieldColumn":"TemplateType","formReference":"none","operator":"equals"},"hideIfNoUserInteractionRequired":false,"distinct":true,"required":false,"autoSelectFirstOption":true,"helpTexts":{"prefix":"","postfix":""},"spacing":{},"type":"dropDown","name":"TotalPageNo","label":"Page numbering","fullyQualifiedName":"TotalPageNo"},{"dataSource":"PPT FooterVisibility","displayColumn":"showDocNo_label","filter":{"column":"templateType","otherFieldName":"TemplateType","fullyQualifiedOtherFieldName":"TemplateType","otherFieldColumn":"TemplateType","formReference":"none","operator":"equals"},"hideIfNoUserInteractionRequired":false,"distinct":true,"required":false,"autoSelectFirstOption":true,"helpTexts":{"prefix":"","postfix":""},"spacing":{},"type":"dropDown","name":"DocNo","label":"Show document number in footer?","fullyQualifiedName":"DocNo"},{"required":false,"placeholder":"","lines":0,"defaultValue":"{{UserProfile.Prepared}}","helpTexts":{"prefix":"","postfix":""},"spacing":{},"type":"textBox","name":"Prepared","label":"Prepared By (Subject Responsible)","fullyQualifiedName":"Prepared"},{"required":false,"placeholder":"","lines":0,"helpTexts":{"prefix":"","postfix":""},"spacing":{},"type":"textBox","name":"ApprovedBy","label":"Approved By (Document Responsible)","fullyQualifiedName":"ApprovedBy"},{"required":false,"placeholder":"","lines":0,"helpTexts":{"prefix":"","postfix":""},"spacing":{},"type":"textBox","name":"Checked","label":"Checked","fullyQualifiedName":"Checked"},{"required":false,"placeholder":"","lines":0,"helpTexts":{"prefix":"","postfix":"(Overwritten with EriDoc values at check-in)"},"spacing":{},"type":"textBox","name":"Reference","label":"Reference","fullyQualifiedName":"Reference"},{"required":false,"placeholder":"","lines":0,"helpTexts":{"prefix":"","postfix":""},"spacing":{},"type":"textBox","name":"Keywords","label":"Keywords","fullyQualifiedName":"Keywords"}],"formDataEntries":[{"name":"DocumentTitle","value":"pYKnA1M1iVGe972lLW237tBCWABVWwTW03TtSWLVXT0="},{"name":"ConfidentialityClass","value":"cT/FOwTWaPknrhRlNMh4SQ=="},{"name":"LanguageCode","value":"5wlu7ZdPxHQj1W0w+yTNSg=="},{"name":"Date","value":"fbd86WXKelPa8nlkyyencA=="},{"name":"TemplateType","value":"5wlu7ZdPxHQj1W0w+yTNSg=="},{"name":"DocTitle","value":"5wlu7ZdPxHQj1W0w+yTNSg=="},{"name":"TotalPageNo","value":"cT/FOwTWaPknrhRlNMh4SQ=="},{"name":"DocNo","value":"5wlu7ZdPxHQj1W0w+yTNSg=="},{"name":"Prepared","value":"fdJUhNIjdwPGv3mvNZlQT4ASrQGRpusVL7uBTgJlxbo="}]}]]></TemplafyFormConfiguration>
-</file>
-
 <file path=customXml/itemProps1.xml><?xml version="1.0" encoding="utf-8"?>
-<ds:datastoreItem xmlns:ds="http://schemas.openxmlformats.org/officeDocument/2006/customXml" ds:itemID="{683FEB75-8CFA-449C-A6B1-B1E4A86A58A1}">
-  <ds:schemaRefs/>
+<ds:datastoreItem xmlns:ds="http://schemas.openxmlformats.org/officeDocument/2006/customXml" ds:itemID="{56F2EE69-0CCA-4F48-BE22-EC4A886C57A7}">
+  <ds:schemaRefs>
+    <ds:schemaRef ds:uri="92e1255f-bb7b-4dc9-b051-584cc104eb44"/>
+    <ds:schemaRef ds:uri="a6550eff-0fc9-443f-8e77-72cbcf778382"/>
+    <ds:schemaRef ds:uri="http://purl.org/dc/dcmitype/"/>
+    <ds:schemaRef ds:uri="http://purl.org/dc/elements/1.1/"/>
+    <ds:schemaRef ds:uri="http://purl.org/dc/terms/"/>
+    <ds:schemaRef ds:uri="http://schemas.microsoft.com/office/2006/documentManagement/types"/>
+    <ds:schemaRef ds:uri="http://schemas.microsoft.com/office/2006/metadata/properties"/>
+    <ds:schemaRef ds:uri="http://schemas.microsoft.com/office/infopath/2007/PartnerControls"/>
+    <ds:schemaRef ds:uri="http://schemas.openxmlformats.org/package/2006/metadata/core-properties"/>
+    <ds:schemaRef ds:uri="http://www.w3.org/XML/1998/namespace"/>
+  </ds:schemaRefs>
 </ds:datastoreItem>
 </file>
 
 <file path=customXml/itemProps10.xml><?xml version="1.0" encoding="utf-8"?>
-<ds:datastoreItem xmlns:ds="http://schemas.openxmlformats.org/officeDocument/2006/customXml" ds:itemID="{32BA7684-6BE4-4F73-B22E-30934AB379B8}">
+<ds:datastoreItem xmlns:ds="http://schemas.openxmlformats.org/officeDocument/2006/customXml" ds:itemID="{D92C3DF5-A179-4E2D-BD20-07044B39171F}">
   <ds:schemaRefs/>
 </ds:datastoreItem>
 </file>
 
 <file path=customXml/itemProps11.xml><?xml version="1.0" encoding="utf-8"?>
-<ds:datastoreItem xmlns:ds="http://schemas.openxmlformats.org/officeDocument/2006/customXml" ds:itemID="{822D38AD-8010-4CD3-BD6B-117CB8DF70A4}">
+<ds:datastoreItem xmlns:ds="http://schemas.openxmlformats.org/officeDocument/2006/customXml" ds:itemID="{B9AEDDE3-EA02-4A8F-B8F8-0606A0AA45FC}">
   <ds:schemaRefs/>
 </ds:datastoreItem>
 </file>
 
 <file path=customXml/itemProps12.xml><?xml version="1.0" encoding="utf-8"?>
+<ds:datastoreItem xmlns:ds="http://schemas.openxmlformats.org/officeDocument/2006/customXml" ds:itemID="{847502A6-7CBE-43AF-BDF6-4D4423521D8C}">
+  <ds:schemaRefs/>
+</ds:datastoreItem>
+</file>
+
+<file path=customXml/itemProps13.xml><?xml version="1.0" encoding="utf-8"?>
+<ds:datastoreItem xmlns:ds="http://schemas.openxmlformats.org/officeDocument/2006/customXml" ds:itemID="{03AF3FDC-ACD1-46F3-A43E-782322DF9816}">
+  <ds:schemaRefs/>
+</ds:datastoreItem>
+</file>
+
+<file path=customXml/itemProps14.xml><?xml version="1.0" encoding="utf-8"?>
 <ds:datastoreItem xmlns:ds="http://schemas.openxmlformats.org/officeDocument/2006/customXml" ds:itemID="{72516535-7702-46AF-9B1F-8623A67A824E}">
   <ds:schemaRefs/>
 </ds:datastoreItem>
 </file>
 
-<file path=customXml/itemProps13.xml><?xml version="1.0" encoding="utf-8"?>
+<file path=customXml/itemProps15.xml><?xml version="1.0" encoding="utf-8"?>
 <ds:datastoreItem xmlns:ds="http://schemas.openxmlformats.org/officeDocument/2006/customXml" ds:itemID="{1CE36EA9-2186-4EB1-871A-8AE59C2A13BB}">
-  <ds:schemaRefs/>
-</ds:datastoreItem>
-</file>
-
-<file path=customXml/itemProps14.xml><?xml version="1.0" encoding="utf-8"?>
-<ds:datastoreItem xmlns:ds="http://schemas.openxmlformats.org/officeDocument/2006/customXml" ds:itemID="{B9AEDDE3-EA02-4A8F-B8F8-0606A0AA45FC}">
-  <ds:schemaRefs/>
-</ds:datastoreItem>
-</file>
-
-<file path=customXml/itemProps15.xml><?xml version="1.0" encoding="utf-8"?>
-<ds:datastoreItem xmlns:ds="http://schemas.openxmlformats.org/officeDocument/2006/customXml" ds:itemID="{C09F197C-6A49-47D0-B877-F88807989676}">
   <ds:schemaRefs/>
 </ds:datastoreItem>
 </file>
@@ -16580,12 +16601,44 @@
 </file>
 
 <file path=customXml/itemProps3.xml><?xml version="1.0" encoding="utf-8"?>
-<ds:datastoreItem xmlns:ds="http://schemas.openxmlformats.org/officeDocument/2006/customXml" ds:itemID="{03AF3FDC-ACD1-46F3-A43E-782322DF9816}">
+<ds:datastoreItem xmlns:ds="http://schemas.openxmlformats.org/officeDocument/2006/customXml" ds:itemID="{683FEB75-8CFA-449C-A6B1-B1E4A86A58A1}">
   <ds:schemaRefs/>
 </ds:datastoreItem>
 </file>
 
 <file path=customXml/itemProps4.xml><?xml version="1.0" encoding="utf-8"?>
+<ds:datastoreItem xmlns:ds="http://schemas.openxmlformats.org/officeDocument/2006/customXml" ds:itemID="{F5A7E41D-6E7F-4B05-AFAB-F540BD4C068B}">
+  <ds:schemaRefs>
+    <ds:schemaRef ds:uri="http://schemas.microsoft.com/sharepoint/v3/contenttype/forms"/>
+  </ds:schemaRefs>
+</ds:datastoreItem>
+</file>
+
+<file path=customXml/itemProps5.xml><?xml version="1.0" encoding="utf-8"?>
+<ds:datastoreItem xmlns:ds="http://schemas.openxmlformats.org/officeDocument/2006/customXml" ds:itemID="{822D38AD-8010-4CD3-BD6B-117CB8DF70A4}">
+  <ds:schemaRefs/>
+</ds:datastoreItem>
+</file>
+
+<file path=customXml/itemProps6.xml><?xml version="1.0" encoding="utf-8"?>
+<ds:datastoreItem xmlns:ds="http://schemas.openxmlformats.org/officeDocument/2006/customXml" ds:itemID="{58CC0B31-82B9-497A-9A2E-F3F72D0BBDAD}">
+  <ds:schemaRefs/>
+</ds:datastoreItem>
+</file>
+
+<file path=customXml/itemProps7.xml><?xml version="1.0" encoding="utf-8"?>
+<ds:datastoreItem xmlns:ds="http://schemas.openxmlformats.org/officeDocument/2006/customXml" ds:itemID="{C09F197C-6A49-47D0-B877-F88807989676}">
+  <ds:schemaRefs/>
+</ds:datastoreItem>
+</file>
+
+<file path=customXml/itemProps8.xml><?xml version="1.0" encoding="utf-8"?>
+<ds:datastoreItem xmlns:ds="http://schemas.openxmlformats.org/officeDocument/2006/customXml" ds:itemID="{32BA7684-6BE4-4F73-B22E-30934AB379B8}">
+  <ds:schemaRefs/>
+</ds:datastoreItem>
+</file>
+
+<file path=customXml/itemProps9.xml><?xml version="1.0" encoding="utf-8"?>
 <ds:datastoreItem xmlns:ds="http://schemas.openxmlformats.org/officeDocument/2006/customXml" ds:itemID="{A2258578-4028-422E-A2BB-56A6BD2305EC}">
   <ds:schemaRefs>
     <ds:schemaRef ds:uri="92e1255f-bb7b-4dc9-b051-584cc104eb44"/>
@@ -16604,49 +16657,6 @@
 </ds:datastoreItem>
 </file>
 
-<file path=customXml/itemProps5.xml><?xml version="1.0" encoding="utf-8"?>
-<ds:datastoreItem xmlns:ds="http://schemas.openxmlformats.org/officeDocument/2006/customXml" ds:itemID="{58CC0B31-82B9-497A-9A2E-F3F72D0BBDAD}">
-  <ds:schemaRefs/>
-</ds:datastoreItem>
-</file>
-
-<file path=customXml/itemProps6.xml><?xml version="1.0" encoding="utf-8"?>
-<ds:datastoreItem xmlns:ds="http://schemas.openxmlformats.org/officeDocument/2006/customXml" ds:itemID="{F5A7E41D-6E7F-4B05-AFAB-F540BD4C068B}">
-  <ds:schemaRefs>
-    <ds:schemaRef ds:uri="http://schemas.microsoft.com/sharepoint/v3/contenttype/forms"/>
-  </ds:schemaRefs>
-</ds:datastoreItem>
-</file>
-
-<file path=customXml/itemProps7.xml><?xml version="1.0" encoding="utf-8"?>
-<ds:datastoreItem xmlns:ds="http://schemas.openxmlformats.org/officeDocument/2006/customXml" ds:itemID="{56F2EE69-0CCA-4F48-BE22-EC4A886C57A7}">
-  <ds:schemaRefs>
-    <ds:schemaRef ds:uri="92e1255f-bb7b-4dc9-b051-584cc104eb44"/>
-    <ds:schemaRef ds:uri="a6550eff-0fc9-443f-8e77-72cbcf778382"/>
-    <ds:schemaRef ds:uri="http://purl.org/dc/dcmitype/"/>
-    <ds:schemaRef ds:uri="http://purl.org/dc/elements/1.1/"/>
-    <ds:schemaRef ds:uri="http://purl.org/dc/terms/"/>
-    <ds:schemaRef ds:uri="http://schemas.microsoft.com/office/2006/documentManagement/types"/>
-    <ds:schemaRef ds:uri="http://schemas.microsoft.com/office/2006/metadata/properties"/>
-    <ds:schemaRef ds:uri="http://schemas.microsoft.com/office/infopath/2007/PartnerControls"/>
-    <ds:schemaRef ds:uri="http://schemas.openxmlformats.org/package/2006/metadata/core-properties"/>
-    <ds:schemaRef ds:uri="http://www.w3.org/XML/1998/namespace"/>
-  </ds:schemaRefs>
-</ds:datastoreItem>
-</file>
-
-<file path=customXml/itemProps8.xml><?xml version="1.0" encoding="utf-8"?>
-<ds:datastoreItem xmlns:ds="http://schemas.openxmlformats.org/officeDocument/2006/customXml" ds:itemID="{847502A6-7CBE-43AF-BDF6-4D4423521D8C}">
-  <ds:schemaRefs/>
-</ds:datastoreItem>
-</file>
-
-<file path=customXml/itemProps9.xml><?xml version="1.0" encoding="utf-8"?>
-<ds:datastoreItem xmlns:ds="http://schemas.openxmlformats.org/officeDocument/2006/customXml" ds:itemID="{D92C3DF5-A179-4E2D-BD20-07044B39171F}">
-  <ds:schemaRefs/>
-</ds:datastoreItem>
-</file>
-
 <file path=docMetadata/LabelInfo.xml><?xml version="1.0" encoding="utf-8"?>
 <clbl:labelList xmlns:clbl="http://schemas.microsoft.com/office/2020/mipLabelMetadata">
   <clbl:label id="{92e84ceb-fbfd-47ab-be52-080c6b87953f}" enabled="0" method="" siteId="{92e84ceb-fbfd-47ab-be52-080c6b87953f}" removed="1"/>

</xml_diff>